<commit_message>
Commit May 2024 replay weather inputs so the replay builds without internet
</commit_message>
<xml_diff>
--- a/docs/Heat_Health_SIH2026.pptx
+++ b/docs/Heat_Health_SIH2026.pptx
@@ -14371,7 +14371,9 @@
               </a:rPr>
               <a:t>GitHub repository</a:t>
             </a:r>
-            <a:br/>
+            <a:br>
+              <a:rPr dirty="0"/>
+            </a:br>
             <a:r>
               <a:rPr lang="en-US" sz="1000" u="sng" dirty="0">
                 <a:solidFill>
@@ -14432,7 +14434,18 @@
                 <a:ea typeface="Calibri" pitchFamily="34" charset="-122"/>
                 <a:cs typeface="Calibri" pitchFamily="34" charset="-120"/>
               </a:rPr>
-              <a:t>Prototype demonstration video: ______</a:t>
+              <a:t>Prototype demonstration video</a:t>
+            </a:r>
+            <a:r>
+              <a:rPr lang="en-US" sz="1150" b="1">
+                <a:solidFill>
+                  <a:srgbClr val="1F2937"/>
+                </a:solidFill>
+                <a:latin typeface="Calibri" pitchFamily="34" charset="0"/>
+                <a:ea typeface="Calibri" pitchFamily="34" charset="-122"/>
+                <a:cs typeface="Calibri" pitchFamily="34" charset="-120"/>
+              </a:rPr>
+              <a:t>: http://youtube.com/watch?v=V4f20cV1iZI</a:t>
             </a:r>
             <a:endParaRPr lang="en-US" sz="1150" dirty="0"/>
           </a:p>

</xml_diff>